<commit_message>
feat: redesign system architecture slide with layered diagram
- Added 4-layer architecture visualization:
  * Client Layer: Streamlit Dashboard, REST API, Telegram Bot, MS Teams
  * API Gateway Layer: FastAPI Core with endpoints (/queries/ask, /documents/upload, /health)
  * Core Services Layer: Query Orchestrator, Intent Classifier, Document Processor, Response Generator, KB Search
  * Data Layer: SQLite, FAISS, File System
- Added External Services section: Ollama LLM
- More detailed component breakdown with proper labeling
</commit_message>
<xml_diff>
--- a/presentation/IntelliKnow_KMS_Introduction.pptx
+++ b/presentation/IntelliKnow_KMS_Introduction.pptx
@@ -2648,8 +2648,8 @@
         </p:nvSpPr>
         <p:spPr>
           <a:xfrm>
-            <a:off x="457200" y="457200"/>
-            <a:ext cx="8229600" cy="548640"/>
+            <a:off x="457200" y="274320"/>
+            <a:ext cx="8229600" cy="457200"/>
           </a:xfrm>
           <a:prstGeom prst="rect">
             <a:avLst/>
@@ -2665,7 +2665,7 @@
               <a:buNone/>
             </a:pPr>
             <a:r>
-              <a:rPr lang="en-US" sz="3600" b="1" dirty="0">
+              <a:rPr lang="en-US" sz="3200" b="1" dirty="0">
                 <a:solidFill>
                   <a:srgbClr val="028090"/>
                 </a:solidFill>
@@ -2675,7 +2675,7 @@
               </a:rPr>
               <a:t>System Architecture</a:t>
             </a:r>
-            <a:endParaRPr lang="en-US" sz="3600" dirty="0"/>
+            <a:endParaRPr lang="en-US" sz="3200" dirty="0"/>
           </a:p>
         </p:txBody>
       </p:sp>
@@ -2687,8 +2687,313 @@
         </p:nvSpPr>
         <p:spPr>
           <a:xfrm>
-            <a:off x="457200" y="1188720"/>
-            <a:ext cx="2560320" cy="1097280"/>
+            <a:off x="274320" y="822960"/>
+            <a:ext cx="8595360" cy="4206240"/>
+          </a:xfrm>
+          <a:prstGeom prst="rect">
+            <a:avLst/>
+          </a:prstGeom>
+          <a:solidFill>
+            <a:srgbClr val="F8F9FA"/>
+          </a:solidFill>
+          <a:ln w="12700">
+            <a:solidFill>
+              <a:srgbClr val="718096"/>
+            </a:solidFill>
+            <a:prstDash val="solid"/>
+          </a:ln>
+        </p:spPr>
+      </p:sp>
+      <p:sp>
+        <p:nvSpPr>
+          <p:cNvPr id="4" name="Shape 2"/>
+          <p:cNvSpPr/>
+          <p:nvPr/>
+        </p:nvSpPr>
+        <p:spPr>
+          <a:xfrm>
+            <a:off x="457200" y="914400"/>
+            <a:ext cx="8229600" cy="548640"/>
+          </a:xfrm>
+          <a:prstGeom prst="rect">
+            <a:avLst/>
+          </a:prstGeom>
+          <a:solidFill>
+            <a:srgbClr val="1B4965"/>
+          </a:solidFill>
+          <a:ln/>
+        </p:spPr>
+      </p:sp>
+      <p:sp>
+        <p:nvSpPr>
+          <p:cNvPr id="5" name="Text 3"/>
+          <p:cNvSpPr/>
+          <p:nvPr/>
+        </p:nvSpPr>
+        <p:spPr>
+          <a:xfrm>
+            <a:off x="457200" y="914400"/>
+            <a:ext cx="8229600" cy="548640"/>
+          </a:xfrm>
+          <a:prstGeom prst="rect">
+            <a:avLst/>
+          </a:prstGeom>
+          <a:noFill/>
+          <a:ln/>
+        </p:spPr>
+        <p:txBody>
+          <a:bodyPr wrap="square" rtlCol="0" anchor="ctr"/>
+          <a:lstStyle/>
+          <a:p>
+            <a:pPr algn="ctr" indent="0" marL="0">
+              <a:buNone/>
+            </a:pPr>
+            <a:r>
+              <a:rPr lang="en-US" sz="1100" b="1" dirty="0">
+                <a:solidFill>
+                  <a:srgbClr val="FFFFFF"/>
+                </a:solidFill>
+              </a:rPr>
+              <a:t>CLIENT LAYER</a:t>
+            </a:r>
+            <a:endParaRPr lang="en-US" sz="1100" dirty="0"/>
+          </a:p>
+        </p:txBody>
+      </p:sp>
+      <p:sp>
+        <p:nvSpPr>
+          <p:cNvPr id="6" name="Shape 4"/>
+          <p:cNvSpPr/>
+          <p:nvPr/>
+        </p:nvSpPr>
+        <p:spPr>
+          <a:xfrm>
+            <a:off x="640080" y="1051560"/>
+            <a:ext cx="1828800" cy="320040"/>
+          </a:xfrm>
+          <a:prstGeom prst="rect">
+            <a:avLst/>
+          </a:prstGeom>
+          <a:solidFill>
+            <a:srgbClr val="5A7D9A"/>
+          </a:solidFill>
+          <a:ln/>
+        </p:spPr>
+      </p:sp>
+      <p:sp>
+        <p:nvSpPr>
+          <p:cNvPr id="7" name="Text 5"/>
+          <p:cNvSpPr/>
+          <p:nvPr/>
+        </p:nvSpPr>
+        <p:spPr>
+          <a:xfrm>
+            <a:off x="640080" y="1051560"/>
+            <a:ext cx="1828800" cy="320040"/>
+          </a:xfrm>
+          <a:prstGeom prst="rect">
+            <a:avLst/>
+          </a:prstGeom>
+          <a:noFill/>
+          <a:ln/>
+        </p:spPr>
+        <p:txBody>
+          <a:bodyPr wrap="square" rtlCol="0" anchor="ctr"/>
+          <a:lstStyle/>
+          <a:p>
+            <a:pPr algn="ctr" indent="0" marL="0">
+              <a:buNone/>
+            </a:pPr>
+            <a:r>
+              <a:rPr lang="en-US" sz="900" dirty="0">
+                <a:solidFill>
+                  <a:srgbClr val="FFFFFF"/>
+                </a:solidFill>
+              </a:rPr>
+              <a:t>Streamlit Dashboard</a:t>
+            </a:r>
+            <a:endParaRPr lang="en-US" sz="900" dirty="0"/>
+          </a:p>
+        </p:txBody>
+      </p:sp>
+      <p:sp>
+        <p:nvSpPr>
+          <p:cNvPr id="8" name="Shape 6"/>
+          <p:cNvSpPr/>
+          <p:nvPr/>
+        </p:nvSpPr>
+        <p:spPr>
+          <a:xfrm>
+            <a:off x="2651760" y="1051560"/>
+            <a:ext cx="1645920" cy="320040"/>
+          </a:xfrm>
+          <a:prstGeom prst="rect">
+            <a:avLst/>
+          </a:prstGeom>
+          <a:solidFill>
+            <a:srgbClr val="5A7D9A"/>
+          </a:solidFill>
+          <a:ln/>
+        </p:spPr>
+      </p:sp>
+      <p:sp>
+        <p:nvSpPr>
+          <p:cNvPr id="9" name="Text 7"/>
+          <p:cNvSpPr/>
+          <p:nvPr/>
+        </p:nvSpPr>
+        <p:spPr>
+          <a:xfrm>
+            <a:off x="2651760" y="1051560"/>
+            <a:ext cx="1645920" cy="320040"/>
+          </a:xfrm>
+          <a:prstGeom prst="rect">
+            <a:avLst/>
+          </a:prstGeom>
+          <a:noFill/>
+          <a:ln/>
+        </p:spPr>
+        <p:txBody>
+          <a:bodyPr wrap="square" rtlCol="0" anchor="ctr"/>
+          <a:lstStyle/>
+          <a:p>
+            <a:pPr algn="ctr" indent="0" marL="0">
+              <a:buNone/>
+            </a:pPr>
+            <a:r>
+              <a:rPr lang="en-US" sz="900" dirty="0">
+                <a:solidFill>
+                  <a:srgbClr val="FFFFFF"/>
+                </a:solidFill>
+              </a:rPr>
+              <a:t>REST API</a:t>
+            </a:r>
+            <a:endParaRPr lang="en-US" sz="900" dirty="0"/>
+          </a:p>
+        </p:txBody>
+      </p:sp>
+      <p:sp>
+        <p:nvSpPr>
+          <p:cNvPr id="10" name="Shape 8"/>
+          <p:cNvSpPr/>
+          <p:nvPr/>
+        </p:nvSpPr>
+        <p:spPr>
+          <a:xfrm>
+            <a:off x="4480560" y="1051560"/>
+            <a:ext cx="1645920" cy="320040"/>
+          </a:xfrm>
+          <a:prstGeom prst="rect">
+            <a:avLst/>
+          </a:prstGeom>
+          <a:solidFill>
+            <a:srgbClr val="5A7D9A"/>
+          </a:solidFill>
+          <a:ln/>
+        </p:spPr>
+      </p:sp>
+      <p:sp>
+        <p:nvSpPr>
+          <p:cNvPr id="11" name="Text 9"/>
+          <p:cNvSpPr/>
+          <p:nvPr/>
+        </p:nvSpPr>
+        <p:spPr>
+          <a:xfrm>
+            <a:off x="4480560" y="1051560"/>
+            <a:ext cx="1645920" cy="320040"/>
+          </a:xfrm>
+          <a:prstGeom prst="rect">
+            <a:avLst/>
+          </a:prstGeom>
+          <a:noFill/>
+          <a:ln/>
+        </p:spPr>
+        <p:txBody>
+          <a:bodyPr wrap="square" rtlCol="0" anchor="ctr"/>
+          <a:lstStyle/>
+          <a:p>
+            <a:pPr algn="ctr" indent="0" marL="0">
+              <a:buNone/>
+            </a:pPr>
+            <a:r>
+              <a:rPr lang="en-US" sz="900" dirty="0">
+                <a:solidFill>
+                  <a:srgbClr val="FFFFFF"/>
+                </a:solidFill>
+              </a:rPr>
+              <a:t>Telegram Bot</a:t>
+            </a:r>
+            <a:endParaRPr lang="en-US" sz="900" dirty="0"/>
+          </a:p>
+        </p:txBody>
+      </p:sp>
+      <p:sp>
+        <p:nvSpPr>
+          <p:cNvPr id="12" name="Shape 10"/>
+          <p:cNvSpPr/>
+          <p:nvPr/>
+        </p:nvSpPr>
+        <p:spPr>
+          <a:xfrm>
+            <a:off x="6309360" y="1051560"/>
+            <a:ext cx="2194560" cy="320040"/>
+          </a:xfrm>
+          <a:prstGeom prst="rect">
+            <a:avLst/>
+          </a:prstGeom>
+          <a:solidFill>
+            <a:srgbClr val="5A7D9A"/>
+          </a:solidFill>
+          <a:ln/>
+        </p:spPr>
+      </p:sp>
+      <p:sp>
+        <p:nvSpPr>
+          <p:cNvPr id="13" name="Text 11"/>
+          <p:cNvSpPr/>
+          <p:nvPr/>
+        </p:nvSpPr>
+        <p:spPr>
+          <a:xfrm>
+            <a:off x="6309360" y="1051560"/>
+            <a:ext cx="2194560" cy="320040"/>
+          </a:xfrm>
+          <a:prstGeom prst="rect">
+            <a:avLst/>
+          </a:prstGeom>
+          <a:noFill/>
+          <a:ln/>
+        </p:spPr>
+        <p:txBody>
+          <a:bodyPr wrap="square" rtlCol="0" anchor="ctr"/>
+          <a:lstStyle/>
+          <a:p>
+            <a:pPr algn="ctr" indent="0" marL="0">
+              <a:buNone/>
+            </a:pPr>
+            <a:r>
+              <a:rPr lang="en-US" sz="900" dirty="0">
+                <a:solidFill>
+                  <a:srgbClr val="FFFFFF"/>
+                </a:solidFill>
+              </a:rPr>
+              <a:t>Microsoft Teams</a:t>
+            </a:r>
+            <a:endParaRPr lang="en-US" sz="900" dirty="0"/>
+          </a:p>
+        </p:txBody>
+      </p:sp>
+      <p:sp>
+        <p:nvSpPr>
+          <p:cNvPr id="14" name="Shape 12"/>
+          <p:cNvSpPr/>
+          <p:nvPr/>
+        </p:nvSpPr>
+        <p:spPr>
+          <a:xfrm>
+            <a:off x="457200" y="1600200"/>
+            <a:ext cx="8229600" cy="548640"/>
           </a:xfrm>
           <a:prstGeom prst="rect">
             <a:avLst/>
@@ -2701,14 +3006,14 @@
       </p:sp>
       <p:sp>
         <p:nvSpPr>
-          <p:cNvPr id="4" name="Text 2"/>
-          <p:cNvSpPr/>
-          <p:nvPr/>
-        </p:nvSpPr>
-        <p:spPr>
-          <a:xfrm>
-            <a:off x="457200" y="1188720"/>
-            <a:ext cx="2560320" cy="1097280"/>
+          <p:cNvPr id="15" name="Text 13"/>
+          <p:cNvSpPr/>
+          <p:nvPr/>
+        </p:nvSpPr>
+        <p:spPr>
+          <a:xfrm>
+            <a:off x="457200" y="1600200"/>
+            <a:ext cx="8229600" cy="548640"/>
           </a:xfrm>
           <a:prstGeom prst="rect">
             <a:avLst/>
@@ -2724,41 +3029,307 @@
               <a:buNone/>
             </a:pPr>
             <a:r>
-              <a:rPr lang="en-US" sz="1400" b="1" dirty="0">
+              <a:rPr lang="en-US" sz="1100" b="1" dirty="0">
                 <a:solidFill>
                   <a:srgbClr val="FFFFFF"/>
                 </a:solidFill>
               </a:rPr>
-              <a:t>Frontend</a:t>
-            </a:r>
-            <a:endParaRPr lang="en-US" sz="1400" dirty="0"/>
-          </a:p>
+              <a:t>API GATEWAY LAYER</a:t>
+            </a:r>
+            <a:endParaRPr lang="en-US" sz="1100" dirty="0"/>
+          </a:p>
+        </p:txBody>
+      </p:sp>
+      <p:sp>
+        <p:nvSpPr>
+          <p:cNvPr id="16" name="Shape 14"/>
+          <p:cNvSpPr/>
+          <p:nvPr/>
+        </p:nvSpPr>
+        <p:spPr>
+          <a:xfrm>
+            <a:off x="640080" y="1737360"/>
+            <a:ext cx="1463040" cy="320040"/>
+          </a:xfrm>
+          <a:prstGeom prst="rect">
+            <a:avLst/>
+          </a:prstGeom>
+          <a:solidFill>
+            <a:srgbClr val="028090"/>
+          </a:solidFill>
+          <a:ln/>
+        </p:spPr>
+      </p:sp>
+      <p:sp>
+        <p:nvSpPr>
+          <p:cNvPr id="17" name="Text 15"/>
+          <p:cNvSpPr/>
+          <p:nvPr/>
+        </p:nvSpPr>
+        <p:spPr>
+          <a:xfrm>
+            <a:off x="640080" y="1737360"/>
+            <a:ext cx="1463040" cy="320040"/>
+          </a:xfrm>
+          <a:prstGeom prst="rect">
+            <a:avLst/>
+          </a:prstGeom>
+          <a:noFill/>
+          <a:ln/>
+        </p:spPr>
+        <p:txBody>
+          <a:bodyPr wrap="square" rtlCol="0" anchor="ctr"/>
+          <a:lstStyle/>
           <a:p>
             <a:pPr algn="ctr" indent="0" marL="0">
               <a:buNone/>
             </a:pPr>
             <a:r>
-              <a:rPr lang="en-US" sz="1400" b="1" dirty="0">
+              <a:rPr lang="en-US" sz="900" dirty="0">
                 <a:solidFill>
                   <a:srgbClr val="FFFFFF"/>
                 </a:solidFill>
               </a:rPr>
-              <a:t>(Streamlit)</a:t>
-            </a:r>
-            <a:endParaRPr lang="en-US" sz="1400" dirty="0"/>
-          </a:p>
-        </p:txBody>
-      </p:sp>
-      <p:sp>
-        <p:nvSpPr>
-          <p:cNvPr id="5" name="Shape 3"/>
-          <p:cNvSpPr/>
-          <p:nvPr/>
-        </p:nvSpPr>
-        <p:spPr>
-          <a:xfrm>
-            <a:off x="3749040" y="1188720"/>
-            <a:ext cx="2560320" cy="1097280"/>
+              <a:t>FastAPI Core</a:t>
+            </a:r>
+            <a:endParaRPr lang="en-US" sz="900" dirty="0"/>
+          </a:p>
+        </p:txBody>
+      </p:sp>
+      <p:sp>
+        <p:nvSpPr>
+          <p:cNvPr id="18" name="Shape 16"/>
+          <p:cNvSpPr/>
+          <p:nvPr/>
+        </p:nvSpPr>
+        <p:spPr>
+          <a:xfrm>
+            <a:off x="2286000" y="1737360"/>
+            <a:ext cx="1280160" cy="320040"/>
+          </a:xfrm>
+          <a:prstGeom prst="rect">
+            <a:avLst/>
+          </a:prstGeom>
+          <a:solidFill>
+            <a:srgbClr val="028090"/>
+          </a:solidFill>
+          <a:ln/>
+        </p:spPr>
+      </p:sp>
+      <p:sp>
+        <p:nvSpPr>
+          <p:cNvPr id="19" name="Text 17"/>
+          <p:cNvSpPr/>
+          <p:nvPr/>
+        </p:nvSpPr>
+        <p:spPr>
+          <a:xfrm>
+            <a:off x="2286000" y="1737360"/>
+            <a:ext cx="1280160" cy="320040"/>
+          </a:xfrm>
+          <a:prstGeom prst="rect">
+            <a:avLst/>
+          </a:prstGeom>
+          <a:noFill/>
+          <a:ln/>
+        </p:spPr>
+        <p:txBody>
+          <a:bodyPr wrap="square" rtlCol="0" anchor="ctr"/>
+          <a:lstStyle/>
+          <a:p>
+            <a:pPr algn="ctr" indent="0" marL="0">
+              <a:buNone/>
+            </a:pPr>
+            <a:r>
+              <a:rPr lang="en-US" sz="800" dirty="0">
+                <a:solidFill>
+                  <a:srgbClr val="FFFFFF"/>
+                </a:solidFill>
+              </a:rPr>
+              <a:t>/queries/ask</a:t>
+            </a:r>
+            <a:endParaRPr lang="en-US" sz="800" dirty="0"/>
+          </a:p>
+        </p:txBody>
+      </p:sp>
+      <p:sp>
+        <p:nvSpPr>
+          <p:cNvPr id="20" name="Shape 18"/>
+          <p:cNvSpPr/>
+          <p:nvPr/>
+        </p:nvSpPr>
+        <p:spPr>
+          <a:xfrm>
+            <a:off x="3749040" y="1737360"/>
+            <a:ext cx="1463040" cy="320040"/>
+          </a:xfrm>
+          <a:prstGeom prst="rect">
+            <a:avLst/>
+          </a:prstGeom>
+          <a:solidFill>
+            <a:srgbClr val="028090"/>
+          </a:solidFill>
+          <a:ln/>
+        </p:spPr>
+      </p:sp>
+      <p:sp>
+        <p:nvSpPr>
+          <p:cNvPr id="21" name="Text 19"/>
+          <p:cNvSpPr/>
+          <p:nvPr/>
+        </p:nvSpPr>
+        <p:spPr>
+          <a:xfrm>
+            <a:off x="3749040" y="1737360"/>
+            <a:ext cx="1463040" cy="320040"/>
+          </a:xfrm>
+          <a:prstGeom prst="rect">
+            <a:avLst/>
+          </a:prstGeom>
+          <a:noFill/>
+          <a:ln/>
+        </p:spPr>
+        <p:txBody>
+          <a:bodyPr wrap="square" rtlCol="0" anchor="ctr"/>
+          <a:lstStyle/>
+          <a:p>
+            <a:pPr algn="ctr" indent="0" marL="0">
+              <a:buNone/>
+            </a:pPr>
+            <a:r>
+              <a:rPr lang="en-US" sz="800" dirty="0">
+                <a:solidFill>
+                  <a:srgbClr val="FFFFFF"/>
+                </a:solidFill>
+              </a:rPr>
+              <a:t>/documents/upload</a:t>
+            </a:r>
+            <a:endParaRPr lang="en-US" sz="800" dirty="0"/>
+          </a:p>
+        </p:txBody>
+      </p:sp>
+      <p:sp>
+        <p:nvSpPr>
+          <p:cNvPr id="22" name="Shape 20"/>
+          <p:cNvSpPr/>
+          <p:nvPr/>
+        </p:nvSpPr>
+        <p:spPr>
+          <a:xfrm>
+            <a:off x="5394960" y="1737360"/>
+            <a:ext cx="1463040" cy="320040"/>
+          </a:xfrm>
+          <a:prstGeom prst="rect">
+            <a:avLst/>
+          </a:prstGeom>
+          <a:solidFill>
+            <a:srgbClr val="028090"/>
+          </a:solidFill>
+          <a:ln/>
+        </p:spPr>
+      </p:sp>
+      <p:sp>
+        <p:nvSpPr>
+          <p:cNvPr id="23" name="Text 21"/>
+          <p:cNvSpPr/>
+          <p:nvPr/>
+        </p:nvSpPr>
+        <p:spPr>
+          <a:xfrm>
+            <a:off x="5394960" y="1737360"/>
+            <a:ext cx="1463040" cy="320040"/>
+          </a:xfrm>
+          <a:prstGeom prst="rect">
+            <a:avLst/>
+          </a:prstGeom>
+          <a:noFill/>
+          <a:ln/>
+        </p:spPr>
+        <p:txBody>
+          <a:bodyPr wrap="square" rtlCol="0" anchor="ctr"/>
+          <a:lstStyle/>
+          <a:p>
+            <a:pPr algn="ctr" indent="0" marL="0">
+              <a:buNone/>
+            </a:pPr>
+            <a:r>
+              <a:rPr lang="en-US" sz="800" dirty="0">
+                <a:solidFill>
+                  <a:srgbClr val="FFFFFF"/>
+                </a:solidFill>
+              </a:rPr>
+              <a:t>/health</a:t>
+            </a:r>
+            <a:endParaRPr lang="en-US" sz="800" dirty="0"/>
+          </a:p>
+        </p:txBody>
+      </p:sp>
+      <p:sp>
+        <p:nvSpPr>
+          <p:cNvPr id="24" name="Shape 22"/>
+          <p:cNvSpPr/>
+          <p:nvPr/>
+        </p:nvSpPr>
+        <p:spPr>
+          <a:xfrm>
+            <a:off x="7040880" y="1737360"/>
+            <a:ext cx="1463040" cy="320040"/>
+          </a:xfrm>
+          <a:prstGeom prst="rect">
+            <a:avLst/>
+          </a:prstGeom>
+          <a:solidFill>
+            <a:srgbClr val="028090"/>
+          </a:solidFill>
+          <a:ln/>
+        </p:spPr>
+      </p:sp>
+      <p:sp>
+        <p:nvSpPr>
+          <p:cNvPr id="25" name="Text 23"/>
+          <p:cNvSpPr/>
+          <p:nvPr/>
+        </p:nvSpPr>
+        <p:spPr>
+          <a:xfrm>
+            <a:off x="7040880" y="1737360"/>
+            <a:ext cx="1463040" cy="320040"/>
+          </a:xfrm>
+          <a:prstGeom prst="rect">
+            <a:avLst/>
+          </a:prstGeom>
+          <a:noFill/>
+          <a:ln/>
+        </p:spPr>
+        <p:txBody>
+          <a:bodyPr wrap="square" rtlCol="0" anchor="ctr"/>
+          <a:lstStyle/>
+          <a:p>
+            <a:pPr algn="ctr" indent="0" marL="0">
+              <a:buNone/>
+            </a:pPr>
+            <a:r>
+              <a:rPr lang="en-US" sz="900" dirty="0">
+                <a:solidFill>
+                  <a:srgbClr val="FFFFFF"/>
+                </a:solidFill>
+              </a:rPr>
+              <a:t>Async Tasks</a:t>
+            </a:r>
+            <a:endParaRPr lang="en-US" sz="900" dirty="0"/>
+          </a:p>
+        </p:txBody>
+      </p:sp>
+      <p:sp>
+        <p:nvSpPr>
+          <p:cNvPr id="26" name="Shape 24"/>
+          <p:cNvSpPr/>
+          <p:nvPr/>
+        </p:nvSpPr>
+        <p:spPr>
+          <a:xfrm>
+            <a:off x="457200" y="2286000"/>
+            <a:ext cx="8229600" cy="914400"/>
           </a:xfrm>
           <a:prstGeom prst="rect">
             <a:avLst/>
@@ -2771,14 +3342,14 @@
       </p:sp>
       <p:sp>
         <p:nvSpPr>
-          <p:cNvPr id="6" name="Text 4"/>
-          <p:cNvSpPr/>
-          <p:nvPr/>
-        </p:nvSpPr>
-        <p:spPr>
-          <a:xfrm>
-            <a:off x="3749040" y="1188720"/>
-            <a:ext cx="2560320" cy="1097280"/>
+          <p:cNvPr id="27" name="Text 25"/>
+          <p:cNvSpPr/>
+          <p:nvPr/>
+        </p:nvSpPr>
+        <p:spPr>
+          <a:xfrm>
+            <a:off x="457200" y="2286000"/>
+            <a:ext cx="8229600" cy="228600"/>
           </a:xfrm>
           <a:prstGeom prst="rect">
             <a:avLst/>
@@ -2794,61 +3365,121 @@
               <a:buNone/>
             </a:pPr>
             <a:r>
-              <a:rPr lang="en-US" sz="1400" b="1" dirty="0">
+              <a:rPr lang="en-US" sz="1100" b="1" dirty="0">
                 <a:solidFill>
                   <a:srgbClr val="FFFFFF"/>
                 </a:solidFill>
               </a:rPr>
-              <a:t>FastAPI</a:t>
-            </a:r>
-            <a:endParaRPr lang="en-US" sz="1400" dirty="0"/>
-          </a:p>
+              <a:t>CORE SERVICES LAYER</a:t>
+            </a:r>
+            <a:endParaRPr lang="en-US" sz="1100" dirty="0"/>
+          </a:p>
+        </p:txBody>
+      </p:sp>
+      <p:sp>
+        <p:nvSpPr>
+          <p:cNvPr id="28" name="Shape 26"/>
+          <p:cNvSpPr/>
+          <p:nvPr/>
+        </p:nvSpPr>
+        <p:spPr>
+          <a:xfrm>
+            <a:off x="640080" y="2560320"/>
+            <a:ext cx="1645920" cy="502920"/>
+          </a:xfrm>
+          <a:prstGeom prst="roundRect">
+            <a:avLst>
+              <a:gd name="adj" fmla="val 9091"/>
+            </a:avLst>
+          </a:prstGeom>
+          <a:solidFill>
+            <a:srgbClr val="00A896"/>
+          </a:solidFill>
+          <a:ln/>
+        </p:spPr>
+      </p:sp>
+      <p:sp>
+        <p:nvSpPr>
+          <p:cNvPr id="29" name="Text 27"/>
+          <p:cNvSpPr/>
+          <p:nvPr/>
+        </p:nvSpPr>
+        <p:spPr>
+          <a:xfrm>
+            <a:off x="640080" y="2560320"/>
+            <a:ext cx="1645920" cy="502920"/>
+          </a:xfrm>
+          <a:prstGeom prst="rect">
+            <a:avLst/>
+          </a:prstGeom>
+          <a:noFill/>
+          <a:ln/>
+        </p:spPr>
+        <p:txBody>
+          <a:bodyPr wrap="square" rtlCol="0" anchor="ctr"/>
+          <a:lstStyle/>
           <a:p>
             <a:pPr algn="ctr" indent="0" marL="0">
               <a:buNone/>
             </a:pPr>
             <a:r>
-              <a:rPr lang="en-US" sz="1400" b="1" dirty="0">
+              <a:rPr lang="en-US" sz="900" dirty="0">
                 <a:solidFill>
                   <a:srgbClr val="FFFFFF"/>
                 </a:solidFill>
               </a:rPr>
-              <a:t>Backend</a:t>
-            </a:r>
-            <a:endParaRPr lang="en-US" sz="1400" dirty="0"/>
-          </a:p>
-        </p:txBody>
-      </p:sp>
-      <p:sp>
-        <p:nvSpPr>
-          <p:cNvPr id="7" name="Shape 5"/>
-          <p:cNvSpPr/>
-          <p:nvPr/>
-        </p:nvSpPr>
-        <p:spPr>
-          <a:xfrm>
-            <a:off x="7040880" y="1188720"/>
-            <a:ext cx="1645920" cy="1097280"/>
-          </a:xfrm>
-          <a:prstGeom prst="rect">
-            <a:avLst/>
+              <a:t>Query</a:t>
+            </a:r>
+            <a:endParaRPr lang="en-US" sz="900" dirty="0"/>
+          </a:p>
+          <a:p>
+            <a:pPr algn="ctr" indent="0" marL="0">
+              <a:buNone/>
+            </a:pPr>
+            <a:r>
+              <a:rPr lang="en-US" sz="900" dirty="0">
+                <a:solidFill>
+                  <a:srgbClr val="FFFFFF"/>
+                </a:solidFill>
+              </a:rPr>
+              <a:t>Orchestrator</a:t>
+            </a:r>
+            <a:endParaRPr lang="en-US" sz="900" dirty="0"/>
+          </a:p>
+        </p:txBody>
+      </p:sp>
+      <p:sp>
+        <p:nvSpPr>
+          <p:cNvPr id="30" name="Shape 28"/>
+          <p:cNvSpPr/>
+          <p:nvPr/>
+        </p:nvSpPr>
+        <p:spPr>
+          <a:xfrm>
+            <a:off x="2468880" y="2560320"/>
+            <a:ext cx="1463040" cy="502920"/>
+          </a:xfrm>
+          <a:prstGeom prst="roundRect">
+            <a:avLst>
+              <a:gd name="adj" fmla="val 9091"/>
+            </a:avLst>
           </a:prstGeom>
           <a:solidFill>
-            <a:srgbClr val="02C39A"/>
+            <a:srgbClr val="00A896"/>
           </a:solidFill>
           <a:ln/>
         </p:spPr>
       </p:sp>
       <p:sp>
         <p:nvSpPr>
-          <p:cNvPr id="8" name="Text 6"/>
-          <p:cNvSpPr/>
-          <p:nvPr/>
-        </p:nvSpPr>
-        <p:spPr>
-          <a:xfrm>
-            <a:off x="7040880" y="1188720"/>
-            <a:ext cx="1645920" cy="1097280"/>
+          <p:cNvPr id="31" name="Text 29"/>
+          <p:cNvSpPr/>
+          <p:nvPr/>
+        </p:nvSpPr>
+        <p:spPr>
+          <a:xfrm>
+            <a:off x="2468880" y="2560320"/>
+            <a:ext cx="1463040" cy="502920"/>
           </a:xfrm>
           <a:prstGeom prst="rect">
             <a:avLst/>
@@ -2864,41 +3495,313 @@
               <a:buNone/>
             </a:pPr>
             <a:r>
-              <a:rPr lang="en-US" sz="1400" b="1" dirty="0">
+              <a:rPr lang="en-US" sz="900" dirty="0">
                 <a:solidFill>
                   <a:srgbClr val="FFFFFF"/>
                 </a:solidFill>
               </a:rPr>
-              <a:t>Ollama</a:t>
-            </a:r>
-            <a:endParaRPr lang="en-US" sz="1400" dirty="0"/>
+              <a:t>Intent</a:t>
+            </a:r>
+            <a:endParaRPr lang="en-US" sz="900" dirty="0"/>
           </a:p>
           <a:p>
             <a:pPr algn="ctr" indent="0" marL="0">
               <a:buNone/>
             </a:pPr>
             <a:r>
-              <a:rPr lang="en-US" sz="1400" b="1" dirty="0">
+              <a:rPr lang="en-US" sz="900" dirty="0">
                 <a:solidFill>
                   <a:srgbClr val="FFFFFF"/>
                 </a:solidFill>
               </a:rPr>
-              <a:t>(LLM)</a:t>
-            </a:r>
-            <a:endParaRPr lang="en-US" sz="1400" dirty="0"/>
-          </a:p>
-        </p:txBody>
-      </p:sp>
-      <p:sp>
-        <p:nvSpPr>
-          <p:cNvPr id="9" name="Shape 7"/>
-          <p:cNvSpPr/>
-          <p:nvPr/>
-        </p:nvSpPr>
-        <p:spPr>
-          <a:xfrm>
-            <a:off x="457200" y="2743200"/>
-            <a:ext cx="2286000" cy="914400"/>
+              <a:t>Classifier</a:t>
+            </a:r>
+            <a:endParaRPr lang="en-US" sz="900" dirty="0"/>
+          </a:p>
+        </p:txBody>
+      </p:sp>
+      <p:sp>
+        <p:nvSpPr>
+          <p:cNvPr id="32" name="Shape 30"/>
+          <p:cNvSpPr/>
+          <p:nvPr/>
+        </p:nvSpPr>
+        <p:spPr>
+          <a:xfrm>
+            <a:off x="4114800" y="2560320"/>
+            <a:ext cx="1645920" cy="502920"/>
+          </a:xfrm>
+          <a:prstGeom prst="roundRect">
+            <a:avLst>
+              <a:gd name="adj" fmla="val 9091"/>
+            </a:avLst>
+          </a:prstGeom>
+          <a:solidFill>
+            <a:srgbClr val="00A896"/>
+          </a:solidFill>
+          <a:ln/>
+        </p:spPr>
+      </p:sp>
+      <p:sp>
+        <p:nvSpPr>
+          <p:cNvPr id="33" name="Text 31"/>
+          <p:cNvSpPr/>
+          <p:nvPr/>
+        </p:nvSpPr>
+        <p:spPr>
+          <a:xfrm>
+            <a:off x="4114800" y="2560320"/>
+            <a:ext cx="1645920" cy="502920"/>
+          </a:xfrm>
+          <a:prstGeom prst="rect">
+            <a:avLst/>
+          </a:prstGeom>
+          <a:noFill/>
+          <a:ln/>
+        </p:spPr>
+        <p:txBody>
+          <a:bodyPr wrap="square" rtlCol="0" anchor="ctr"/>
+          <a:lstStyle/>
+          <a:p>
+            <a:pPr algn="ctr" indent="0" marL="0">
+              <a:buNone/>
+            </a:pPr>
+            <a:r>
+              <a:rPr lang="en-US" sz="900" dirty="0">
+                <a:solidFill>
+                  <a:srgbClr val="FFFFFF"/>
+                </a:solidFill>
+              </a:rPr>
+              <a:t>Document</a:t>
+            </a:r>
+            <a:endParaRPr lang="en-US" sz="900" dirty="0"/>
+          </a:p>
+          <a:p>
+            <a:pPr algn="ctr" indent="0" marL="0">
+              <a:buNone/>
+            </a:pPr>
+            <a:r>
+              <a:rPr lang="en-US" sz="900" dirty="0">
+                <a:solidFill>
+                  <a:srgbClr val="FFFFFF"/>
+                </a:solidFill>
+              </a:rPr>
+              <a:t>Processor</a:t>
+            </a:r>
+            <a:endParaRPr lang="en-US" sz="900" dirty="0"/>
+          </a:p>
+        </p:txBody>
+      </p:sp>
+      <p:sp>
+        <p:nvSpPr>
+          <p:cNvPr id="34" name="Shape 32"/>
+          <p:cNvSpPr/>
+          <p:nvPr/>
+        </p:nvSpPr>
+        <p:spPr>
+          <a:xfrm>
+            <a:off x="5943600" y="2560320"/>
+            <a:ext cx="1463040" cy="502920"/>
+          </a:xfrm>
+          <a:prstGeom prst="roundRect">
+            <a:avLst>
+              <a:gd name="adj" fmla="val 9091"/>
+            </a:avLst>
+          </a:prstGeom>
+          <a:solidFill>
+            <a:srgbClr val="00A896"/>
+          </a:solidFill>
+          <a:ln/>
+        </p:spPr>
+      </p:sp>
+      <p:sp>
+        <p:nvSpPr>
+          <p:cNvPr id="35" name="Text 33"/>
+          <p:cNvSpPr/>
+          <p:nvPr/>
+        </p:nvSpPr>
+        <p:spPr>
+          <a:xfrm>
+            <a:off x="5943600" y="2560320"/>
+            <a:ext cx="1463040" cy="502920"/>
+          </a:xfrm>
+          <a:prstGeom prst="rect">
+            <a:avLst/>
+          </a:prstGeom>
+          <a:noFill/>
+          <a:ln/>
+        </p:spPr>
+        <p:txBody>
+          <a:bodyPr wrap="square" rtlCol="0" anchor="ctr"/>
+          <a:lstStyle/>
+          <a:p>
+            <a:pPr algn="ctr" indent="0" marL="0">
+              <a:buNone/>
+            </a:pPr>
+            <a:r>
+              <a:rPr lang="en-US" sz="900" dirty="0">
+                <a:solidFill>
+                  <a:srgbClr val="FFFFFF"/>
+                </a:solidFill>
+              </a:rPr>
+              <a:t>Response</a:t>
+            </a:r>
+            <a:endParaRPr lang="en-US" sz="900" dirty="0"/>
+          </a:p>
+          <a:p>
+            <a:pPr algn="ctr" indent="0" marL="0">
+              <a:buNone/>
+            </a:pPr>
+            <a:r>
+              <a:rPr lang="en-US" sz="900" dirty="0">
+                <a:solidFill>
+                  <a:srgbClr val="FFFFFF"/>
+                </a:solidFill>
+              </a:rPr>
+              <a:t>Generator</a:t>
+            </a:r>
+            <a:endParaRPr lang="en-US" sz="900" dirty="0"/>
+          </a:p>
+        </p:txBody>
+      </p:sp>
+      <p:sp>
+        <p:nvSpPr>
+          <p:cNvPr id="36" name="Shape 34"/>
+          <p:cNvSpPr/>
+          <p:nvPr/>
+        </p:nvSpPr>
+        <p:spPr>
+          <a:xfrm>
+            <a:off x="7589520" y="2560320"/>
+            <a:ext cx="914400" cy="502920"/>
+          </a:xfrm>
+          <a:prstGeom prst="roundRect">
+            <a:avLst>
+              <a:gd name="adj" fmla="val 9091"/>
+            </a:avLst>
+          </a:prstGeom>
+          <a:solidFill>
+            <a:srgbClr val="00A896"/>
+          </a:solidFill>
+          <a:ln/>
+        </p:spPr>
+      </p:sp>
+      <p:sp>
+        <p:nvSpPr>
+          <p:cNvPr id="37" name="Text 35"/>
+          <p:cNvSpPr/>
+          <p:nvPr/>
+        </p:nvSpPr>
+        <p:spPr>
+          <a:xfrm>
+            <a:off x="7589520" y="2560320"/>
+            <a:ext cx="914400" cy="502920"/>
+          </a:xfrm>
+          <a:prstGeom prst="rect">
+            <a:avLst/>
+          </a:prstGeom>
+          <a:noFill/>
+          <a:ln/>
+        </p:spPr>
+        <p:txBody>
+          <a:bodyPr wrap="square" rtlCol="0" anchor="ctr"/>
+          <a:lstStyle/>
+          <a:p>
+            <a:pPr algn="ctr" indent="0" marL="0">
+              <a:buNone/>
+            </a:pPr>
+            <a:r>
+              <a:rPr lang="en-US" sz="800" dirty="0">
+                <a:solidFill>
+                  <a:srgbClr val="FFFFFF"/>
+                </a:solidFill>
+              </a:rPr>
+              <a:t>KB</a:t>
+            </a:r>
+            <a:endParaRPr lang="en-US" sz="800" dirty="0"/>
+          </a:p>
+          <a:p>
+            <a:pPr algn="ctr" indent="0" marL="0">
+              <a:buNone/>
+            </a:pPr>
+            <a:r>
+              <a:rPr lang="en-US" sz="800" dirty="0">
+                <a:solidFill>
+                  <a:srgbClr val="FFFFFF"/>
+                </a:solidFill>
+              </a:rPr>
+              <a:t>Search</a:t>
+            </a:r>
+            <a:endParaRPr lang="en-US" sz="800" dirty="0"/>
+          </a:p>
+        </p:txBody>
+      </p:sp>
+      <p:sp>
+        <p:nvSpPr>
+          <p:cNvPr id="38" name="Shape 36"/>
+          <p:cNvSpPr/>
+          <p:nvPr/>
+        </p:nvSpPr>
+        <p:spPr>
+          <a:xfrm>
+            <a:off x="457200" y="3337560"/>
+            <a:ext cx="5943600" cy="685800"/>
+          </a:xfrm>
+          <a:prstGeom prst="rect">
+            <a:avLst/>
+          </a:prstGeom>
+          <a:solidFill>
+            <a:srgbClr val="1B4965"/>
+          </a:solidFill>
+          <a:ln/>
+        </p:spPr>
+      </p:sp>
+      <p:sp>
+        <p:nvSpPr>
+          <p:cNvPr id="39" name="Text 37"/>
+          <p:cNvSpPr/>
+          <p:nvPr/>
+        </p:nvSpPr>
+        <p:spPr>
+          <a:xfrm>
+            <a:off x="457200" y="3337560"/>
+            <a:ext cx="5943600" cy="228600"/>
+          </a:xfrm>
+          <a:prstGeom prst="rect">
+            <a:avLst/>
+          </a:prstGeom>
+          <a:noFill/>
+          <a:ln/>
+        </p:spPr>
+        <p:txBody>
+          <a:bodyPr wrap="square" rtlCol="0" anchor="ctr"/>
+          <a:lstStyle/>
+          <a:p>
+            <a:pPr algn="ctr" indent="0" marL="0">
+              <a:buNone/>
+            </a:pPr>
+            <a:r>
+              <a:rPr lang="en-US" sz="1100" b="1" dirty="0">
+                <a:solidFill>
+                  <a:srgbClr val="FFFFFF"/>
+                </a:solidFill>
+              </a:rPr>
+              <a:t>DATA LAYER</a:t>
+            </a:r>
+            <a:endParaRPr lang="en-US" sz="1100" dirty="0"/>
+          </a:p>
+        </p:txBody>
+      </p:sp>
+      <p:sp>
+        <p:nvSpPr>
+          <p:cNvPr id="40" name="Shape 38"/>
+          <p:cNvSpPr/>
+          <p:nvPr/>
+        </p:nvSpPr>
+        <p:spPr>
+          <a:xfrm>
+            <a:off x="640080" y="3520440"/>
+            <a:ext cx="1645920" cy="411480"/>
           </a:xfrm>
           <a:prstGeom prst="cylinder">
             <a:avLst/>
@@ -2906,7 +3809,7 @@
           <a:solidFill>
             <a:srgbClr val="EDF2F7"/>
           </a:solidFill>
-          <a:ln w="25400">
+          <a:ln w="12700">
             <a:solidFill>
               <a:srgbClr val="1B4965"/>
             </a:solidFill>
@@ -2916,14 +3819,14 @@
       </p:sp>
       <p:sp>
         <p:nvSpPr>
-          <p:cNvPr id="10" name="Text 8"/>
-          <p:cNvSpPr/>
-          <p:nvPr/>
-        </p:nvSpPr>
-        <p:spPr>
-          <a:xfrm>
-            <a:off x="457200" y="2743200"/>
-            <a:ext cx="2286000" cy="914400"/>
+          <p:cNvPr id="41" name="Text 39"/>
+          <p:cNvSpPr/>
+          <p:nvPr/>
+        </p:nvSpPr>
+        <p:spPr>
+          <a:xfrm>
+            <a:off x="640080" y="3520440"/>
+            <a:ext cx="1645920" cy="411480"/>
           </a:xfrm>
           <a:prstGeom prst="rect">
             <a:avLst/>
@@ -2939,41 +3842,41 @@
               <a:buNone/>
             </a:pPr>
             <a:r>
-              <a:rPr lang="en-US" sz="1200" b="1" dirty="0">
+              <a:rPr lang="en-US" sz="800" b="1" dirty="0">
                 <a:solidFill>
                   <a:srgbClr val="1B4965"/>
                 </a:solidFill>
               </a:rPr>
               <a:t>SQLite</a:t>
             </a:r>
-            <a:endParaRPr lang="en-US" sz="1200" dirty="0"/>
+            <a:endParaRPr lang="en-US" sz="800" dirty="0"/>
           </a:p>
           <a:p>
             <a:pPr algn="ctr" indent="0" marL="0">
               <a:buNone/>
             </a:pPr>
             <a:r>
-              <a:rPr lang="en-US" sz="1200" b="1" dirty="0">
+              <a:rPr lang="en-US" sz="800" b="1" dirty="0">
                 <a:solidFill>
                   <a:srgbClr val="1B4965"/>
                 </a:solidFill>
               </a:rPr>
-              <a:t>(Metadata)</a:t>
-            </a:r>
-            <a:endParaRPr lang="en-US" sz="1200" dirty="0"/>
-          </a:p>
-        </p:txBody>
-      </p:sp>
-      <p:sp>
-        <p:nvSpPr>
-          <p:cNvPr id="11" name="Shape 9"/>
-          <p:cNvSpPr/>
-          <p:nvPr/>
-        </p:nvSpPr>
-        <p:spPr>
-          <a:xfrm>
-            <a:off x="3200400" y="2743200"/>
-            <a:ext cx="2286000" cy="914400"/>
+              <a:t>Metadata</a:t>
+            </a:r>
+            <a:endParaRPr lang="en-US" sz="800" dirty="0"/>
+          </a:p>
+        </p:txBody>
+      </p:sp>
+      <p:sp>
+        <p:nvSpPr>
+          <p:cNvPr id="42" name="Shape 40"/>
+          <p:cNvSpPr/>
+          <p:nvPr/>
+        </p:nvSpPr>
+        <p:spPr>
+          <a:xfrm>
+            <a:off x="2468880" y="3520440"/>
+            <a:ext cx="1645920" cy="411480"/>
           </a:xfrm>
           <a:prstGeom prst="cylinder">
             <a:avLst/>
@@ -2981,7 +3884,7 @@
           <a:solidFill>
             <a:srgbClr val="EDF2F7"/>
           </a:solidFill>
-          <a:ln w="25400">
+          <a:ln w="12700">
             <a:solidFill>
               <a:srgbClr val="1B4965"/>
             </a:solidFill>
@@ -2991,14 +3894,14 @@
       </p:sp>
       <p:sp>
         <p:nvSpPr>
-          <p:cNvPr id="12" name="Text 10"/>
-          <p:cNvSpPr/>
-          <p:nvPr/>
-        </p:nvSpPr>
-        <p:spPr>
-          <a:xfrm>
-            <a:off x="3200400" y="2743200"/>
-            <a:ext cx="2286000" cy="914400"/>
+          <p:cNvPr id="43" name="Text 41"/>
+          <p:cNvSpPr/>
+          <p:nvPr/>
+        </p:nvSpPr>
+        <p:spPr>
+          <a:xfrm>
+            <a:off x="2468880" y="3520440"/>
+            <a:ext cx="1645920" cy="411480"/>
           </a:xfrm>
           <a:prstGeom prst="rect">
             <a:avLst/>
@@ -3014,41 +3917,41 @@
               <a:buNone/>
             </a:pPr>
             <a:r>
-              <a:rPr lang="en-US" sz="1200" b="1" dirty="0">
+              <a:rPr lang="en-US" sz="800" b="1" dirty="0">
                 <a:solidFill>
                   <a:srgbClr val="1B4965"/>
                 </a:solidFill>
               </a:rPr>
               <a:t>FAISS</a:t>
             </a:r>
-            <a:endParaRPr lang="en-US" sz="1200" dirty="0"/>
+            <a:endParaRPr lang="en-US" sz="800" dirty="0"/>
           </a:p>
           <a:p>
             <a:pPr algn="ctr" indent="0" marL="0">
               <a:buNone/>
             </a:pPr>
             <a:r>
-              <a:rPr lang="en-US" sz="1200" b="1" dirty="0">
+              <a:rPr lang="en-US" sz="800" b="1" dirty="0">
                 <a:solidFill>
                   <a:srgbClr val="1B4965"/>
                 </a:solidFill>
               </a:rPr>
-              <a:t>(Vectors)</a:t>
-            </a:r>
-            <a:endParaRPr lang="en-US" sz="1200" dirty="0"/>
-          </a:p>
-        </p:txBody>
-      </p:sp>
-      <p:sp>
-        <p:nvSpPr>
-          <p:cNvPr id="13" name="Shape 11"/>
-          <p:cNvSpPr/>
-          <p:nvPr/>
-        </p:nvSpPr>
-        <p:spPr>
-          <a:xfrm>
-            <a:off x="5943600" y="2743200"/>
-            <a:ext cx="2286000" cy="914400"/>
+              <a:t>Vectors</a:t>
+            </a:r>
+            <a:endParaRPr lang="en-US" sz="800" dirty="0"/>
+          </a:p>
+        </p:txBody>
+      </p:sp>
+      <p:sp>
+        <p:nvSpPr>
+          <p:cNvPr id="44" name="Shape 42"/>
+          <p:cNvSpPr/>
+          <p:nvPr/>
+        </p:nvSpPr>
+        <p:spPr>
+          <a:xfrm>
+            <a:off x="4297680" y="3520440"/>
+            <a:ext cx="1645920" cy="411480"/>
           </a:xfrm>
           <a:prstGeom prst="cylinder">
             <a:avLst/>
@@ -3056,7 +3959,7 @@
           <a:solidFill>
             <a:srgbClr val="EDF2F7"/>
           </a:solidFill>
-          <a:ln w="25400">
+          <a:ln w="12700">
             <a:solidFill>
               <a:srgbClr val="1B4965"/>
             </a:solidFill>
@@ -3066,14 +3969,14 @@
       </p:sp>
       <p:sp>
         <p:nvSpPr>
-          <p:cNvPr id="14" name="Text 12"/>
-          <p:cNvSpPr/>
-          <p:nvPr/>
-        </p:nvSpPr>
-        <p:spPr>
-          <a:xfrm>
-            <a:off x="5943600" y="2743200"/>
-            <a:ext cx="2286000" cy="914400"/>
+          <p:cNvPr id="45" name="Text 43"/>
+          <p:cNvSpPr/>
+          <p:nvPr/>
+        </p:nvSpPr>
+        <p:spPr>
+          <a:xfrm>
+            <a:off x="4297680" y="3520440"/>
+            <a:ext cx="1645920" cy="411480"/>
           </a:xfrm>
           <a:prstGeom prst="rect">
             <a:avLst/>
@@ -3089,192 +3992,192 @@
               <a:buNone/>
             </a:pPr>
             <a:r>
-              <a:rPr lang="en-US" sz="1200" b="1" dirty="0">
+              <a:rPr lang="en-US" sz="800" b="1" dirty="0">
                 <a:solidFill>
                   <a:srgbClr val="1B4965"/>
                 </a:solidFill>
               </a:rPr>
               <a:t>File System</a:t>
             </a:r>
-            <a:endParaRPr lang="en-US" sz="1200" dirty="0"/>
+            <a:endParaRPr lang="en-US" sz="800" dirty="0"/>
           </a:p>
           <a:p>
             <a:pPr algn="ctr" indent="0" marL="0">
               <a:buNone/>
             </a:pPr>
             <a:r>
-              <a:rPr lang="en-US" sz="1200" b="1" dirty="0">
+              <a:rPr lang="en-US" sz="800" b="1" dirty="0">
                 <a:solidFill>
                   <a:srgbClr val="1B4965"/>
                 </a:solidFill>
               </a:rPr>
-              <a:t>(Documents)</a:t>
-            </a:r>
-            <a:endParaRPr lang="en-US" sz="1200" dirty="0"/>
-          </a:p>
-        </p:txBody>
-      </p:sp>
-      <p:sp>
-        <p:nvSpPr>
-          <p:cNvPr id="15" name="Shape 13"/>
-          <p:cNvSpPr/>
-          <p:nvPr/>
-        </p:nvSpPr>
-        <p:spPr>
-          <a:xfrm>
-            <a:off x="3749040" y="2286000"/>
-            <a:ext cx="0" cy="457200"/>
-          </a:xfrm>
-          <a:prstGeom prst="line">
+              <a:t>Documents</a:t>
+            </a:r>
+            <a:endParaRPr lang="en-US" sz="800" dirty="0"/>
+          </a:p>
+        </p:txBody>
+      </p:sp>
+      <p:sp>
+        <p:nvSpPr>
+          <p:cNvPr id="46" name="Shape 44"/>
+          <p:cNvSpPr/>
+          <p:nvPr/>
+        </p:nvSpPr>
+        <p:spPr>
+          <a:xfrm>
+            <a:off x="6583680" y="3337560"/>
+            <a:ext cx="2103120" cy="685800"/>
+          </a:xfrm>
+          <a:prstGeom prst="rect">
+            <a:avLst/>
+          </a:prstGeom>
+          <a:solidFill>
+            <a:srgbClr val="02C39A"/>
+          </a:solidFill>
+          <a:ln/>
+        </p:spPr>
+      </p:sp>
+      <p:sp>
+        <p:nvSpPr>
+          <p:cNvPr id="47" name="Text 45"/>
+          <p:cNvSpPr/>
+          <p:nvPr/>
+        </p:nvSpPr>
+        <p:spPr>
+          <a:xfrm>
+            <a:off x="6583680" y="3337560"/>
+            <a:ext cx="2103120" cy="182880"/>
+          </a:xfrm>
+          <a:prstGeom prst="rect">
             <a:avLst/>
           </a:prstGeom>
           <a:noFill/>
-          <a:ln w="25400">
-            <a:solidFill>
-              <a:srgbClr val="718096"/>
-            </a:solidFill>
-            <a:prstDash val="dash"/>
-          </a:ln>
-        </p:spPr>
-      </p:sp>
-      <p:sp>
-        <p:nvSpPr>
-          <p:cNvPr id="16" name="Shape 14"/>
-          <p:cNvSpPr/>
-          <p:nvPr/>
-        </p:nvSpPr>
-        <p:spPr>
-          <a:xfrm>
-            <a:off x="3749040" y="2743200"/>
-            <a:ext cx="-1463040" cy="0"/>
-          </a:xfrm>
-          <a:prstGeom prst="line">
+          <a:ln/>
+        </p:spPr>
+        <p:txBody>
+          <a:bodyPr wrap="square" rtlCol="0" anchor="ctr"/>
+          <a:lstStyle/>
+          <a:p>
+            <a:pPr algn="ctr" indent="0" marL="0">
+              <a:buNone/>
+            </a:pPr>
+            <a:r>
+              <a:rPr lang="en-US" sz="1000" b="1" dirty="0">
+                <a:solidFill>
+                  <a:srgbClr val="FFFFFF"/>
+                </a:solidFill>
+              </a:rPr>
+              <a:t>EXTERNAL SERVICES</a:t>
+            </a:r>
+            <a:endParaRPr lang="en-US" sz="1000" dirty="0"/>
+          </a:p>
+        </p:txBody>
+      </p:sp>
+      <p:sp>
+        <p:nvSpPr>
+          <p:cNvPr id="48" name="Shape 46"/>
+          <p:cNvSpPr/>
+          <p:nvPr/>
+        </p:nvSpPr>
+        <p:spPr>
+          <a:xfrm>
+            <a:off x="6766560" y="3520440"/>
+            <a:ext cx="1737360" cy="411480"/>
+          </a:xfrm>
+          <a:prstGeom prst="roundRect">
+            <a:avLst>
+              <a:gd name="adj" fmla="val 11111"/>
+            </a:avLst>
+          </a:prstGeom>
+          <a:solidFill>
+            <a:srgbClr val="02C39A"/>
+          </a:solidFill>
+          <a:ln/>
+        </p:spPr>
+      </p:sp>
+      <p:sp>
+        <p:nvSpPr>
+          <p:cNvPr id="49" name="Text 47"/>
+          <p:cNvSpPr/>
+          <p:nvPr/>
+        </p:nvSpPr>
+        <p:spPr>
+          <a:xfrm>
+            <a:off x="6766560" y="3520440"/>
+            <a:ext cx="1737360" cy="411480"/>
+          </a:xfrm>
+          <a:prstGeom prst="rect">
             <a:avLst/>
           </a:prstGeom>
           <a:noFill/>
-          <a:ln w="25400">
-            <a:solidFill>
-              <a:srgbClr val="718096"/>
-            </a:solidFill>
-            <a:prstDash val="dash"/>
-          </a:ln>
-        </p:spPr>
-      </p:sp>
-      <p:sp>
-        <p:nvSpPr>
-          <p:cNvPr id="17" name="Shape 15"/>
-          <p:cNvSpPr/>
-          <p:nvPr/>
-        </p:nvSpPr>
-        <p:spPr>
-          <a:xfrm>
-            <a:off x="3749040" y="2743200"/>
-            <a:ext cx="1280160" cy="0"/>
-          </a:xfrm>
-          <a:prstGeom prst="line">
+          <a:ln/>
+        </p:spPr>
+        <p:txBody>
+          <a:bodyPr wrap="square" rtlCol="0" anchor="ctr"/>
+          <a:lstStyle/>
+          <a:p>
+            <a:pPr algn="ctr" indent="0" marL="0">
+              <a:buNone/>
+            </a:pPr>
+            <a:r>
+              <a:rPr lang="en-US" sz="800" dirty="0">
+                <a:solidFill>
+                  <a:srgbClr val="FFFFFF"/>
+                </a:solidFill>
+              </a:rPr>
+              <a:t>Ollama LLM</a:t>
+            </a:r>
+            <a:endParaRPr lang="en-US" sz="800" dirty="0"/>
+          </a:p>
+          <a:p>
+            <a:pPr algn="ctr" indent="0" marL="0">
+              <a:buNone/>
+            </a:pPr>
+            <a:r>
+              <a:rPr lang="en-US" sz="800" dirty="0">
+                <a:solidFill>
+                  <a:srgbClr val="FFFFFF"/>
+                </a:solidFill>
+              </a:rPr>
+              <a:t>(qwen:0.5b)</a:t>
+            </a:r>
+            <a:endParaRPr lang="en-US" sz="800" dirty="0"/>
+          </a:p>
+        </p:txBody>
+      </p:sp>
+      <p:sp>
+        <p:nvSpPr>
+          <p:cNvPr id="50" name="Text 48"/>
+          <p:cNvSpPr/>
+          <p:nvPr/>
+        </p:nvSpPr>
+        <p:spPr>
+          <a:xfrm>
+            <a:off x="457200" y="4160520"/>
+            <a:ext cx="8229600" cy="228600"/>
+          </a:xfrm>
+          <a:prstGeom prst="rect">
             <a:avLst/>
           </a:prstGeom>
           <a:noFill/>
-          <a:ln w="25400">
-            <a:solidFill>
-              <a:srgbClr val="718096"/>
-            </a:solidFill>
-            <a:prstDash val="dash"/>
-          </a:ln>
-        </p:spPr>
-      </p:sp>
-      <p:sp>
-        <p:nvSpPr>
-          <p:cNvPr id="18" name="Shape 16"/>
-          <p:cNvSpPr/>
-          <p:nvPr/>
-        </p:nvSpPr>
-        <p:spPr>
-          <a:xfrm>
-            <a:off x="5943600" y="2743200"/>
-            <a:ext cx="1097280" cy="0"/>
-          </a:xfrm>
-          <a:prstGeom prst="line">
-            <a:avLst/>
-          </a:prstGeom>
-          <a:noFill/>
-          <a:ln w="25400">
-            <a:solidFill>
-              <a:srgbClr val="718096"/>
-            </a:solidFill>
-            <a:prstDash val="dash"/>
-          </a:ln>
-        </p:spPr>
-      </p:sp>
-      <p:sp>
-        <p:nvSpPr>
-          <p:cNvPr id="19" name="Text 17"/>
-          <p:cNvSpPr/>
-          <p:nvPr/>
-        </p:nvSpPr>
-        <p:spPr>
-          <a:xfrm>
-            <a:off x="457200" y="4114800"/>
-            <a:ext cx="8229600" cy="274320"/>
-          </a:xfrm>
-          <a:prstGeom prst="rect">
-            <a:avLst/>
-          </a:prstGeom>
-          <a:noFill/>
           <a:ln/>
         </p:spPr>
         <p:txBody>
           <a:bodyPr wrap="square" rtlCol="0" anchor="ctr"/>
           <a:lstStyle/>
           <a:p>
-            <a:pPr indent="0" marL="0">
-              <a:buNone/>
-            </a:pPr>
-            <a:r>
-              <a:rPr lang="en-US" sz="1400" b="1" dirty="0">
-                <a:solidFill>
-                  <a:srgbClr val="028090"/>
-                </a:solidFill>
-              </a:rPr>
-              <a:t>Technology Stack</a:t>
-            </a:r>
-            <a:endParaRPr lang="en-US" sz="1400" dirty="0"/>
-          </a:p>
-        </p:txBody>
-      </p:sp>
-      <p:sp>
-        <p:nvSpPr>
-          <p:cNvPr id="20" name="Text 18"/>
-          <p:cNvSpPr/>
-          <p:nvPr/>
-        </p:nvSpPr>
-        <p:spPr>
-          <a:xfrm>
-            <a:off x="457200" y="4389120"/>
-            <a:ext cx="8229600" cy="274320"/>
-          </a:xfrm>
-          <a:prstGeom prst="rect">
-            <a:avLst/>
-          </a:prstGeom>
-          <a:noFill/>
-          <a:ln/>
-        </p:spPr>
-        <p:txBody>
-          <a:bodyPr wrap="square" rtlCol="0" anchor="ctr"/>
-          <a:lstStyle/>
-          <a:p>
-            <a:pPr indent="0" marL="0">
-              <a:buNone/>
-            </a:pPr>
-            <a:r>
-              <a:rPr lang="en-US" sz="1200" dirty="0">
+            <a:pPr algn="ctr" indent="0" marL="0">
+              <a:buNone/>
+            </a:pPr>
+            <a:r>
+              <a:rPr lang="en-US" sz="1000" dirty="0">
                 <a:solidFill>
                   <a:srgbClr val="2D3748"/>
                 </a:solidFill>
               </a:rPr>
-              <a:t>Python 3.10 | FastAPI | SQLAlchemy | FAISS | Sentence-Transformers | Ollama | Docker | Streamlit</a:t>
-            </a:r>
-            <a:endParaRPr lang="en-US" sz="1200" dirty="0"/>
+              <a:t>Python 3.10 | FastAPI | SQLAlchemy | FAISS | Sentence-Transformers | Ollama | Docker</a:t>
+            </a:r>
+            <a:endParaRPr lang="en-US" sz="1000" dirty="0"/>
           </a:p>
         </p:txBody>
       </p:sp>

</xml_diff>